<commit_message>
Kit 3 founder slots filled; second story slot removed at owners' direction
- Katelyn's 8th grade literature story (scaffolds over stretching)
- Shared take: the forgotten top end; build the stretch on purpose
- Adam's practice: leveled safety texts and quizzes, equal understanding
- Slide-12 story slot removed (owners had no authentic example)

Co-Authored-By: Claude Opus 5 <noreply@anthropic.com>
Claude-Session: https://claude.ai/code/session_01UrWWr3vbRywthE5aNZWdnr
</commit_message>
<xml_diff>
--- a/kits/kit03/Kit03_PresentationDeck.pptx
+++ b/kits/kit03/Kit03_PresentationDeck.pptx
@@ -795,7 +795,7 @@
           <a:p>
             <a:r>
               <a:rPr lang="en-US" dirty="0"/>
-              <a:t>Crossley et al. 2022: the CommonLit CLEAR corpus grounded readability in teacher judgment; level is a testable property, not a vibe. FOUNDER STORY slot lands here: the time a level label was wrong and how you caught it.</a:t>
+              <a:t>Crossley et al. 2022: the CommonLit CLEAR corpus grounded readability in teacher judgment; level is a testable property, not a vibe. Teach the three quick checks (read aloud, sentence length, try on one student) and move on.</a:t>
             </a:r>
             <a:endParaRPr lang="en-US" dirty="0"/>
           </a:p>
@@ -1323,7 +1323,7 @@
           <a:p>
             <a:r>
               <a:rPr lang="en-US" dirty="0"/>
-              <a:t>That’s from RAND (RR-A134-25): the schools whose students most need differentiated materials are least likely to be getting AI’s help making them. YOUR TAKE slot lands here; read the authors’ stated position from the script.</a:t>
+              <a:t>That’s from RAND (RR-A134-25): the schools whose students most need differentiated materials are least likely to be getting AI’s help making them. Then read the authors’ shared take from the script: in practice, equity tends to favor the struggling child, and the top end of the class gets forgotten; now that extensions cost two minutes, build the stretch on purpose.</a:t>
             </a:r>
             <a:endParaRPr lang="en-US" dirty="0"/>
           </a:p>
@@ -1411,7 +1411,7 @@
           <a:p>
             <a:r>
               <a:rPr lang="en-US" dirty="0"/>
-              <a:t>Pairs, devices out inside two minutes, announce the tool. LOCAL EXAMPLE slot: read one of the authors’ real differentiation prompts from the script (Adam’s leveled shop-safety procedure or Katelyn’s read-aloud-to-centers prompt).</a:t>
+              <a:t>Pairs, devices out inside two minutes, announce the tool. Then read Adam’s practice from the script: he levels the reading level of safety training materials and their tests/quizzes so every student understands equally; in a shop, comprehension is fingers.</a:t>
             </a:r>
             <a:endParaRPr lang="en-US" dirty="0"/>
           </a:p>
@@ -1499,7 +1499,7 @@
           <a:p>
             <a:r>
               <a:rPr lang="en-US" dirty="0"/>
-              <a:t>Deunk et al. 2018, Educational Research Review: grouping alone is not enough; the materials have to actually differ. FOUNDER STORY slot lands here; read Katelyn’s three-versions story from the script.</a:t>
+              <a:t>Deunk et al. 2018, Educational Research Review: grouping alone is not enough; the materials have to actually differ. Then read Katelyn’s story from the script: in her 8th grade literature class, scaffolds took precedence over stretching; when versions are hand-built, the stretch gets triaged.</a:t>
             </a:r>
             <a:endParaRPr lang="en-US" dirty="0"/>
           </a:p>

</xml_diff>

<commit_message>
Kit 3: universal lab-exemplar retrofit (owner directive)
Ms. Rivera follows one artifact through the whole lab: her 6th grade
food webs reading passage, drafted in step 1, given support and stretch
versions in step 2, then run through the 4-point review in step 3. Deck
slides 20-22 carry her passage as large teal exemplar cards; chips and
script rivera-lines name the same passage at every step.

Co-Authored-By: Claude Fable 5 <noreply@anthropic.com>
Claude-Session: https://claude.ai/code/session_019agQ42s1igQaB2X7GGat9R
</commit_message>
<xml_diff>
--- a/kits/kit03/Kit03_PresentationDeck.pptx
+++ b/kits/kit03/Kit03_PresentationDeck.pptx
@@ -1411,7 +1411,7 @@
           <a:p>
             <a:r>
               <a:rPr lang="en-US" dirty="0"/>
-              <a:t>Pairs, devices out inside two minutes, announce the tool. The standard to name here: differentiate until understanding is equal, and let AI do the drafting that used to make that impossible.</a:t>
+              <a:t>Pairs, devices out inside two minutes, announce the tool. The standard to name here: differentiate until understanding is equal, and let AI do the drafting that used to make that impossible. Ms. Rivera builds ONE artifact across all three steps, the reading passage for her 6th grade food webs lesson; her exemplar appears large on every step slide, so anyone lost can copy her structure.</a:t>
             </a:r>
             <a:endParaRPr lang="en-US" dirty="0"/>
           </a:p>
@@ -1587,7 +1587,7 @@
           <a:p>
             <a:r>
               <a:rPr lang="en-US" dirty="0"/>
-              <a:t>Circulate. Weak drafts usually lack context; nudge with “what would a substitute need to know about this lesson?”</a:t>
+              <a:t>Circulate. Weak drafts usually lack context; nudge with “what would a substitute need to know about this lesson?” The big card is Ms. Rivera’s step 1: one reading passage for her 6th grade food webs lesson, drafted to 80%. The same passage runs through all three steps; anyone stuck can copy her structure.</a:t>
             </a:r>
             <a:endParaRPr lang="en-US" dirty="0"/>
           </a:p>
@@ -1675,7 +1675,7 @@
           <a:p>
             <a:r>
               <a:rPr lang="en-US" dirty="0"/>
-              <a:t>Two follow-up prompts in the same chat. 45-min cut: one direction instead of two; each teacher picks support or stretch based on their roster.</a:t>
+              <a:t>Two follow-up prompts in the same chat. The big card is Ms. Rivera's step 2 on the same food webs passage: the leveled support version, then three depth prompts. Mimic her pair of follow-ups with your own artifact. 45-min cut: one direction instead of two; each teacher picks support or stretch based on their roster.</a:t>
             </a:r>
             <a:endParaRPr lang="en-US" dirty="0"/>
           </a:p>
@@ -1763,7 +1763,7 @@
           <a:p>
             <a:r>
               <a:rPr lang="en-US" dirty="0"/>
-              <a:t>Insist on this step; skipping review is the failure mode of the whole kit. Pairs swap and check each other’s level labels: a partner’s ear is the first check.</a:t>
+              <a:t>Insist on this step; skipping review is the failure mode of the whole kit. Pairs swap and check each other’s level labels: a partner’s ear is the first check. The big card is Ms. Rivera's review run on the same food webs passage: two points fail, two fixes happen live, and only then is it done.</a:t>
             </a:r>
             <a:endParaRPr lang="en-US" dirty="0"/>
           </a:p>
@@ -1851,7 +1851,7 @@
           <a:p>
             <a:r>
               <a:rPr lang="en-US" dirty="0"/>
-              <a:t>Prioritize anyone whose review caught a real problem; it’s the most useful minute in the room. 45-min cut: two voices. Keep each to a minute.</a:t>
+              <a:t>Prioritize anyone whose review caught a real problem; it’s the most useful minute in the room. Ms. Rivera's model story is on the chip: what the review caught in her food webs passage goes first. 45-min cut: two voices. Keep each to a minute.</a:t>
             </a:r>
             <a:endParaRPr lang="en-US" dirty="0"/>
           </a:p>
@@ -11494,7 +11494,7 @@
                 <a:ea typeface="Inter" pitchFamily="34" charset="-122"/>
                 <a:cs typeface="Inter" pitchFamily="34" charset="-120"/>
               </a:rPr>
-              <a:t>Her lab: the lesson she brought, differentiated two directions.</a:t>
+              <a:t>Her lab pick, one artifact all the way through: her 6th grade food webs passage.</a:t>
             </a:r>
             <a:endParaRPr lang="en-US" sz="1000" dirty="0"/>
           </a:p>
@@ -12991,7 +12991,7 @@
                 <a:ea typeface="Inter" pitchFamily="34" charset="-122"/>
                 <a:cs typeface="Inter" pitchFamily="34" charset="-120"/>
               </a:rPr>
-              <a:t>On her screen: the core artifact, drafted to 80%, not polished.</a:t>
+              <a:t>On her screen big: her food webs passage, drafted to 80%, not polished.</a:t>
             </a:r>
             <a:endParaRPr lang="en-US" sz="1000" dirty="0"/>
           </a:p>
@@ -13077,26 +13077,132 @@
       </p:sp>
       <p:sp>
         <p:nvSpPr>
-          <p:cNvPr id="14" name="Shape 11"/>
-          <p:cNvSpPr/>
-          <p:nvPr/>
-        </p:nvSpPr>
-        <p:spPr>
-          <a:xfrm>
-            <a:off x="640080" y="1508760"/>
-            <a:ext cx="10972800" cy="731520"/>
+          <p:cNvPr id="14" name="Text 11"/>
+          <p:cNvSpPr/>
+          <p:nvPr/>
+        </p:nvSpPr>
+        <p:spPr>
+          <a:xfrm>
+            <a:off x="640080" y="1554480"/>
+            <a:ext cx="5394960" cy="4023360"/>
+          </a:xfrm>
+          <a:prstGeom prst="rect">
+            <a:avLst/>
+          </a:prstGeom>
+          <a:noFill/>
+          <a:ln/>
+        </p:spPr>
+        <p:txBody>
+          <a:bodyPr wrap="square" rtlCol="0" anchor="t"/>
+          <a:lstStyle/>
+          <a:p>
+            <a:pPr marL="342900" indent="-342900">
+              <a:spcAft>
+                <a:spcPts val="1000"/>
+              </a:spcAft>
+              <a:buSzPct val="100000"/>
+              <a:buChar char="•"/>
+            </a:pPr>
+            <a:r>
+              <a:rPr lang="en-US" sz="1650" dirty="0">
+                <a:solidFill>
+                  <a:srgbClr val="1B1F24"/>
+                </a:solidFill>
+                <a:latin typeface="Inter" pitchFamily="34" charset="0"/>
+                <a:ea typeface="Inter" pitchFamily="34" charset="-122"/>
+                <a:cs typeface="Inter" pitchFamily="34" charset="-120"/>
+              </a:rPr>
+              <a:t>Pick the one artifact your lesson most needs: reading, practice set, directions, exit check</a:t>
+            </a:r>
+            <a:endParaRPr lang="en-US" sz="1650" dirty="0"/>
+          </a:p>
+          <a:p>
+            <a:pPr marL="342900" indent="-342900">
+              <a:spcAft>
+                <a:spcPts val="1000"/>
+              </a:spcAft>
+              <a:buSzPct val="100000"/>
+              <a:buChar char="•"/>
+            </a:pPr>
+            <a:r>
+              <a:rPr lang="en-US" sz="1650" dirty="0">
+                <a:solidFill>
+                  <a:srgbClr val="1B1F24"/>
+                </a:solidFill>
+                <a:latin typeface="Inter" pitchFamily="34" charset="0"/>
+                <a:ea typeface="Inter" pitchFamily="34" charset="-122"/>
+                <a:cs typeface="Inter" pitchFamily="34" charset="-120"/>
+              </a:rPr>
+              <a:t>Role · task · context · format, and be generous with context</a:t>
+            </a:r>
+            <a:endParaRPr lang="en-US" sz="1650" dirty="0"/>
+          </a:p>
+          <a:p>
+            <a:pPr marL="342900" indent="-342900">
+              <a:spcAft>
+                <a:spcPts val="1000"/>
+              </a:spcAft>
+              <a:buSzPct val="100000"/>
+              <a:buChar char="•"/>
+            </a:pPr>
+            <a:r>
+              <a:rPr lang="en-US" sz="1650" dirty="0">
+                <a:solidFill>
+                  <a:srgbClr val="1B1F24"/>
+                </a:solidFill>
+                <a:latin typeface="Inter" pitchFamily="34" charset="0"/>
+                <a:ea typeface="Inter" pitchFamily="34" charset="-122"/>
+                <a:cs typeface="Inter" pitchFamily="34" charset="-120"/>
+              </a:rPr>
+              <a:t>What did students just learn? What do they always trip on?</a:t>
+            </a:r>
+            <a:endParaRPr lang="en-US" sz="1650" dirty="0"/>
+          </a:p>
+          <a:p>
+            <a:pPr marL="342900" indent="-342900">
+              <a:spcAft>
+                <a:spcPts val="1000"/>
+              </a:spcAft>
+              <a:buSzPct val="100000"/>
+              <a:buChar char="•"/>
+            </a:pPr>
+            <a:r>
+              <a:rPr lang="en-US" sz="1650" dirty="0">
+                <a:solidFill>
+                  <a:srgbClr val="1B1F24"/>
+                </a:solidFill>
+                <a:latin typeface="Inter" pitchFamily="34" charset="0"/>
+                <a:ea typeface="Inter" pitchFamily="34" charset="-122"/>
+                <a:cs typeface="Inter" pitchFamily="34" charset="-120"/>
+              </a:rPr>
+              <a:t>Run it. Read like an editor. Get it to 80%, not perfect.</a:t>
+            </a:r>
+            <a:endParaRPr lang="en-US" sz="1650" dirty="0"/>
+          </a:p>
+        </p:txBody>
+      </p:sp>
+      <p:sp>
+        <p:nvSpPr>
+          <p:cNvPr id="15" name="Shape 12"/>
+          <p:cNvSpPr/>
+          <p:nvPr/>
+        </p:nvSpPr>
+        <p:spPr>
+          <a:xfrm>
+            <a:off x="6263640" y="1554480"/>
+            <a:ext cx="5394960" cy="4023360"/>
           </a:xfrm>
           <a:prstGeom prst="roundRect">
             <a:avLst>
-              <a:gd name="adj" fmla="val 11250"/>
+              <a:gd name="adj" fmla="val 2045"/>
             </a:avLst>
           </a:prstGeom>
           <a:solidFill>
-            <a:srgbClr val="F7F5F0"/>
+            <a:srgbClr val="EAF5F3"/>
           </a:solidFill>
           <a:ln w="12700">
             <a:solidFill>
-              <a:srgbClr val="F7F5F0"/>
+              <a:srgbClr val="EAF5F3"/>
             </a:solidFill>
             <a:prstDash val="solid"/>
           </a:ln>
@@ -13104,30 +13210,89 @@
       </p:sp>
       <p:sp>
         <p:nvSpPr>
-          <p:cNvPr id="15" name="Text 12"/>
-          <p:cNvSpPr/>
-          <p:nvPr/>
-        </p:nvSpPr>
-        <p:spPr>
-          <a:xfrm>
-            <a:off x="960120" y="1563624"/>
-            <a:ext cx="10332720" cy="621792"/>
-          </a:xfrm>
-          <a:prstGeom prst="rect">
-            <a:avLst/>
-          </a:prstGeom>
-          <a:noFill/>
-          <a:ln/>
-        </p:spPr>
-        <p:txBody>
-          <a:bodyPr wrap="square" lIns="0" tIns="0" rIns="0" bIns="0" rtlCol="0" anchor="ctr"/>
-          <a:lstStyle/>
-          <a:p>
-            <a:pPr indent="0" marL="0">
-              <a:buNone/>
-            </a:pPr>
-            <a:r>
-              <a:rPr lang="en-US" sz="1800" dirty="0">
+          <p:cNvPr id="16" name="Text 13"/>
+          <p:cNvSpPr/>
+          <p:nvPr/>
+        </p:nvSpPr>
+        <p:spPr>
+          <a:xfrm>
+            <a:off x="6537960" y="1737360"/>
+            <a:ext cx="4937760" cy="292608"/>
+          </a:xfrm>
+          <a:prstGeom prst="rect">
+            <a:avLst/>
+          </a:prstGeom>
+          <a:noFill/>
+          <a:ln/>
+        </p:spPr>
+        <p:txBody>
+          <a:bodyPr wrap="square" lIns="0" tIns="0" rIns="0" bIns="0" rtlCol="0" anchor="ctr"/>
+          <a:lstStyle/>
+          <a:p>
+            <a:pPr indent="0" marL="0">
+              <a:buNone/>
+            </a:pPr>
+            <a:r>
+              <a:rPr lang="en-US" sz="1250" b="1" spc="150" kern="0" dirty="0">
+                <a:solidFill>
+                  <a:srgbClr val="2A9D8F"/>
+                </a:solidFill>
+                <a:latin typeface="Inter" pitchFamily="34" charset="0"/>
+                <a:ea typeface="Inter" pitchFamily="34" charset="-122"/>
+                <a:cs typeface="Inter" pitchFamily="34" charset="-120"/>
+              </a:rPr>
+              <a:t>MS. RIVERA'S PASSAGE · STEP 1</a:t>
+            </a:r>
+            <a:endParaRPr lang="en-US" sz="1250" dirty="0"/>
+          </a:p>
+        </p:txBody>
+      </p:sp>
+      <p:sp>
+        <p:nvSpPr>
+          <p:cNvPr id="17" name="Text 14"/>
+          <p:cNvSpPr/>
+          <p:nvPr/>
+        </p:nvSpPr>
+        <p:spPr>
+          <a:xfrm>
+            <a:off x="6537960" y="2148840"/>
+            <a:ext cx="4892040" cy="3291840"/>
+          </a:xfrm>
+          <a:prstGeom prst="rect">
+            <a:avLst/>
+          </a:prstGeom>
+          <a:noFill/>
+          <a:ln/>
+        </p:spPr>
+        <p:txBody>
+          <a:bodyPr wrap="square" lIns="0" tIns="0" rIns="0" bIns="0" rtlCol="0" anchor="t"/>
+          <a:lstStyle/>
+          <a:p>
+            <a:pPr indent="0" marL="0">
+              <a:lnSpc>
+                <a:spcPct val="120000"/>
+              </a:lnSpc>
+              <a:buNone/>
+            </a:pPr>
+            <a:r>
+              <a:rPr lang="en-US" sz="1650" b="1" dirty="0">
+                <a:solidFill>
+                  <a:srgbClr val="13293D"/>
+                </a:solidFill>
+                <a:latin typeface="Inter" pitchFamily="34" charset="0"/>
+                <a:ea typeface="Inter" pitchFamily="34" charset="-122"/>
+                <a:cs typeface="Inter" pitchFamily="34" charset="-120"/>
+              </a:rPr>
+              <a:t>Her pick: </a:t>
+            </a:r>
+            <a:pPr indent="0" marL="0">
+              <a:lnSpc>
+                <a:spcPct val="120000"/>
+              </a:lnSpc>
+              <a:buNone/>
+            </a:pPr>
+            <a:r>
+              <a:rPr lang="en-US" sz="1650" dirty="0">
                 <a:solidFill>
                   <a:srgbClr val="1B1F24"/>
                 </a:solidFill>
@@ -13135,65 +13300,35 @@
                 <a:ea typeface="Inter" pitchFamily="34" charset="-122"/>
                 <a:cs typeface="Inter" pitchFamily="34" charset="-120"/>
               </a:rPr>
-              <a:t>Pick the one artifact your lesson most needs: reading, practice set, directions, exit check</a:t>
-            </a:r>
-            <a:endParaRPr lang="en-US" sz="1800" dirty="0"/>
-          </a:p>
-        </p:txBody>
-      </p:sp>
-      <p:sp>
-        <p:nvSpPr>
-          <p:cNvPr id="16" name="Shape 13"/>
-          <p:cNvSpPr/>
-          <p:nvPr/>
-        </p:nvSpPr>
-        <p:spPr>
-          <a:xfrm>
-            <a:off x="640080" y="2377440"/>
-            <a:ext cx="10972800" cy="731520"/>
-          </a:xfrm>
-          <a:prstGeom prst="roundRect">
-            <a:avLst>
-              <a:gd name="adj" fmla="val 11250"/>
-            </a:avLst>
-          </a:prstGeom>
-          <a:solidFill>
-            <a:srgbClr val="F7F5F0"/>
-          </a:solidFill>
-          <a:ln w="12700">
-            <a:solidFill>
-              <a:srgbClr val="F7F5F0"/>
-            </a:solidFill>
-            <a:prstDash val="solid"/>
-          </a:ln>
-        </p:spPr>
-      </p:sp>
-      <p:sp>
-        <p:nvSpPr>
-          <p:cNvPr id="17" name="Text 14"/>
-          <p:cNvSpPr/>
-          <p:nvPr/>
-        </p:nvSpPr>
-        <p:spPr>
-          <a:xfrm>
-            <a:off x="960120" y="2432304"/>
-            <a:ext cx="10332720" cy="621792"/>
-          </a:xfrm>
-          <a:prstGeom prst="rect">
-            <a:avLst/>
-          </a:prstGeom>
-          <a:noFill/>
-          <a:ln/>
-        </p:spPr>
-        <p:txBody>
-          <a:bodyPr wrap="square" lIns="0" tIns="0" rIns="0" bIns="0" rtlCol="0" anchor="ctr"/>
-          <a:lstStyle/>
-          <a:p>
-            <a:pPr indent="0" marL="0">
-              <a:buNone/>
-            </a:pPr>
-            <a:r>
-              <a:rPr lang="en-US" sz="1800" dirty="0">
+              <a:t>the reading passage for her 6th grade food webs lesson.
+</a:t>
+            </a:r>
+            <a:pPr indent="0" marL="0">
+              <a:lnSpc>
+                <a:spcPct val="120000"/>
+              </a:lnSpc>
+              <a:buNone/>
+            </a:pPr>
+            <a:r>
+              <a:rPr lang="en-US" sz="1650" b="1" dirty="0">
+                <a:solidFill>
+                  <a:srgbClr val="13293D"/>
+                </a:solidFill>
+                <a:latin typeface="Inter" pitchFamily="34" charset="0"/>
+                <a:ea typeface="Inter" pitchFamily="34" charset="-122"/>
+                <a:cs typeface="Inter" pitchFamily="34" charset="-120"/>
+              </a:rPr>
+              <a:t>“Food Webs: Energy on the Move”
+</a:t>
+            </a:r>
+            <a:pPr indent="0" marL="0">
+              <a:lnSpc>
+                <a:spcPct val="120000"/>
+              </a:lnSpc>
+              <a:buNone/>
+            </a:pPr>
+            <a:r>
+              <a:rPr lang="en-US" sz="1650" dirty="0">
                 <a:solidFill>
                   <a:srgbClr val="1B1F24"/>
                 </a:solidFill>
@@ -13201,153 +13336,39 @@
                 <a:ea typeface="Inter" pitchFamily="34" charset="-122"/>
                 <a:cs typeface="Inter" pitchFamily="34" charset="-120"/>
               </a:rPr>
-              <a:t>Role · task · context · format, and be generous with context</a:t>
-            </a:r>
-            <a:endParaRPr lang="en-US" sz="1800" dirty="0"/>
-          </a:p>
-        </p:txBody>
-      </p:sp>
-      <p:sp>
-        <p:nvSpPr>
-          <p:cNvPr id="18" name="Shape 15"/>
-          <p:cNvSpPr/>
-          <p:nvPr/>
-        </p:nvSpPr>
-        <p:spPr>
-          <a:xfrm>
-            <a:off x="640080" y="3246120"/>
-            <a:ext cx="10972800" cy="731520"/>
-          </a:xfrm>
-          <a:prstGeom prst="roundRect">
-            <a:avLst>
-              <a:gd name="adj" fmla="val 11250"/>
-            </a:avLst>
-          </a:prstGeom>
-          <a:solidFill>
-            <a:srgbClr val="F7F5F0"/>
-          </a:solidFill>
-          <a:ln w="12700">
-            <a:solidFill>
-              <a:srgbClr val="F7F5F0"/>
-            </a:solidFill>
-            <a:prstDash val="solid"/>
-          </a:ln>
-        </p:spPr>
-      </p:sp>
-      <p:sp>
-        <p:nvSpPr>
-          <p:cNvPr id="19" name="Text 16"/>
-          <p:cNvSpPr/>
-          <p:nvPr/>
-        </p:nvSpPr>
-        <p:spPr>
-          <a:xfrm>
-            <a:off x="960120" y="3300984"/>
-            <a:ext cx="10332720" cy="621792"/>
-          </a:xfrm>
-          <a:prstGeom prst="rect">
-            <a:avLst/>
-          </a:prstGeom>
-          <a:noFill/>
-          <a:ln/>
-        </p:spPr>
-        <p:txBody>
-          <a:bodyPr wrap="square" lIns="0" tIns="0" rIns="0" bIns="0" rtlCol="0" anchor="ctr"/>
-          <a:lstStyle/>
-          <a:p>
-            <a:pPr indent="0" marL="0">
-              <a:buNone/>
-            </a:pPr>
-            <a:r>
-              <a:rPr lang="en-US" sz="1800" dirty="0">
-                <a:solidFill>
-                  <a:srgbClr val="1B1F24"/>
-                </a:solidFill>
-                <a:latin typeface="Inter" pitchFamily="34" charset="0"/>
-                <a:ea typeface="Inter" pitchFamily="34" charset="-122"/>
-                <a:cs typeface="Inter" pitchFamily="34" charset="-120"/>
-              </a:rPr>
-              <a:t>What did students just learn? What do they always trip on?</a:t>
-            </a:r>
-            <a:endParaRPr lang="en-US" sz="1800" dirty="0"/>
-          </a:p>
-        </p:txBody>
-      </p:sp>
-      <p:sp>
-        <p:nvSpPr>
-          <p:cNvPr id="20" name="Shape 17"/>
-          <p:cNvSpPr/>
-          <p:nvPr/>
-        </p:nvSpPr>
-        <p:spPr>
-          <a:xfrm>
-            <a:off x="640080" y="4114800"/>
-            <a:ext cx="10972800" cy="731520"/>
-          </a:xfrm>
-          <a:prstGeom prst="roundRect">
-            <a:avLst>
-              <a:gd name="adj" fmla="val 11250"/>
-            </a:avLst>
-          </a:prstGeom>
-          <a:solidFill>
-            <a:srgbClr val="F7F5F0"/>
-          </a:solidFill>
-          <a:ln w="12700">
-            <a:solidFill>
-              <a:srgbClr val="F7F5F0"/>
-            </a:solidFill>
-            <a:prstDash val="solid"/>
-          </a:ln>
-        </p:spPr>
-      </p:sp>
-      <p:sp>
-        <p:nvSpPr>
-          <p:cNvPr id="21" name="Text 18"/>
-          <p:cNvSpPr/>
-          <p:nvPr/>
-        </p:nvSpPr>
-        <p:spPr>
-          <a:xfrm>
-            <a:off x="960120" y="4169664"/>
-            <a:ext cx="10332720" cy="621792"/>
-          </a:xfrm>
-          <a:prstGeom prst="rect">
-            <a:avLst/>
-          </a:prstGeom>
-          <a:noFill/>
-          <a:ln/>
-        </p:spPr>
-        <p:txBody>
-          <a:bodyPr wrap="square" lIns="0" tIns="0" rIns="0" bIns="0" rtlCol="0" anchor="ctr"/>
-          <a:lstStyle/>
-          <a:p>
-            <a:pPr indent="0" marL="0">
-              <a:buNone/>
-            </a:pPr>
-            <a:r>
-              <a:rPr lang="en-US" sz="1800" dirty="0">
-                <a:solidFill>
-                  <a:srgbClr val="1B1F24"/>
-                </a:solidFill>
-                <a:latin typeface="Inter" pitchFamily="34" charset="0"/>
-                <a:ea typeface="Inter" pitchFamily="34" charset="-122"/>
-                <a:cs typeface="Inter" pitchFamily="34" charset="-120"/>
-              </a:rPr>
-              <a:t>Run it. Read like an editor. Get it to 80%, not perfect.</a:t>
-            </a:r>
-            <a:endParaRPr lang="en-US" sz="1800" dirty="0"/>
-          </a:p>
-        </p:txBody>
-      </p:sp>
-      <p:sp>
-        <p:nvSpPr>
-          <p:cNvPr id="22" name="Text 19"/>
-          <p:cNvSpPr/>
-          <p:nvPr/>
-        </p:nvSpPr>
-        <p:spPr>
-          <a:xfrm>
-            <a:off x="640080" y="5212080"/>
+              <a:t>Four sections, drafted with the formula: what a food web shows · producers and consumers · decomposers · when one link breaks.
+</a:t>
+            </a:r>
+            <a:pPr indent="0" marL="0">
+              <a:lnSpc>
+                <a:spcPct val="120000"/>
+              </a:lnSpc>
+              <a:buNone/>
+            </a:pPr>
+            <a:r>
+              <a:rPr lang="en-US" sz="1650" i="1" dirty="0">
+                <a:solidFill>
+                  <a:srgbClr val="5B6B7A"/>
+                </a:solidFill>
+                <a:latin typeface="Inter" pitchFamily="34" charset="0"/>
+                <a:ea typeface="Inter" pitchFamily="34" charset="-122"/>
+                <a:cs typeface="Inter" pitchFamily="34" charset="-120"/>
+              </a:rPr>
+              <a:t>“Eighty percent is enough. The polish waits for the review.”</a:t>
+            </a:r>
+            <a:endParaRPr lang="en-US" sz="1650" dirty="0"/>
+          </a:p>
+        </p:txBody>
+      </p:sp>
+      <p:sp>
+        <p:nvSpPr>
+          <p:cNvPr id="18" name="Text 15"/>
+          <p:cNvSpPr/>
+          <p:nvPr/>
+        </p:nvSpPr>
+        <p:spPr>
+          <a:xfrm>
+            <a:off x="640080" y="5715000"/>
             <a:ext cx="10972800" cy="457200"/>
           </a:xfrm>
           <a:prstGeom prst="rect">
@@ -13727,7 +13748,7 @@
                 <a:ea typeface="Inter" pitchFamily="34" charset="-122"/>
                 <a:cs typeface="Inter" pitchFamily="34" charset="-120"/>
               </a:rPr>
-              <a:t>Her two follow-ups in the same chat: support version, then stretch.</a:t>
+              <a:t>Her passage's two follow-ups, same chat: the support version, then the stretch.</a:t>
             </a:r>
             <a:endParaRPr lang="en-US" sz="1000" dirty="0"/>
           </a:p>
@@ -13820,11 +13841,221 @@
         <p:spPr>
           <a:xfrm>
             <a:off x="640080" y="1554480"/>
-            <a:ext cx="5394960" cy="3840480"/>
+            <a:ext cx="5394960" cy="1874520"/>
           </a:xfrm>
           <a:prstGeom prst="roundRect">
             <a:avLst>
-              <a:gd name="adj" fmla="val 2143"/>
+              <a:gd name="adj" fmla="val 4390"/>
+            </a:avLst>
+          </a:prstGeom>
+          <a:solidFill>
+            <a:srgbClr val="F7F5F0"/>
+          </a:solidFill>
+          <a:ln w="12700">
+            <a:solidFill>
+              <a:srgbClr val="F7F5F0"/>
+            </a:solidFill>
+            <a:prstDash val="solid"/>
+          </a:ln>
+        </p:spPr>
+      </p:sp>
+      <p:sp>
+        <p:nvSpPr>
+          <p:cNvPr id="15" name="Text 12"/>
+          <p:cNvSpPr/>
+          <p:nvPr/>
+        </p:nvSpPr>
+        <p:spPr>
+          <a:xfrm>
+            <a:off x="914400" y="1719072"/>
+            <a:ext cx="4846320" cy="384048"/>
+          </a:xfrm>
+          <a:prstGeom prst="rect">
+            <a:avLst/>
+          </a:prstGeom>
+          <a:noFill/>
+          <a:ln/>
+        </p:spPr>
+        <p:txBody>
+          <a:bodyPr wrap="square" lIns="0" tIns="0" rIns="0" bIns="0" rtlCol="0" anchor="ctr"/>
+          <a:lstStyle/>
+          <a:p>
+            <a:pPr indent="0" marL="0">
+              <a:buNone/>
+            </a:pPr>
+            <a:r>
+              <a:rPr lang="en-US" sz="1900" b="1" dirty="0">
+                <a:solidFill>
+                  <a:srgbClr val="2E7D5B"/>
+                </a:solidFill>
+                <a:latin typeface="Inter" pitchFamily="34" charset="0"/>
+                <a:ea typeface="Inter" pitchFamily="34" charset="-122"/>
+                <a:cs typeface="Inter" pitchFamily="34" charset="-120"/>
+              </a:rPr>
+              <a:t>Support</a:t>
+            </a:r>
+            <a:endParaRPr lang="en-US" sz="1900" dirty="0"/>
+          </a:p>
+        </p:txBody>
+      </p:sp>
+      <p:sp>
+        <p:nvSpPr>
+          <p:cNvPr id="16" name="Text 13"/>
+          <p:cNvSpPr/>
+          <p:nvPr/>
+        </p:nvSpPr>
+        <p:spPr>
+          <a:xfrm>
+            <a:off x="914400" y="2139696"/>
+            <a:ext cx="4846320" cy="1188720"/>
+          </a:xfrm>
+          <a:prstGeom prst="rect">
+            <a:avLst/>
+          </a:prstGeom>
+          <a:noFill/>
+          <a:ln/>
+        </p:spPr>
+        <p:txBody>
+          <a:bodyPr wrap="square" lIns="0" tIns="0" rIns="0" bIns="0" rtlCol="0" anchor="t"/>
+          <a:lstStyle/>
+          <a:p>
+            <a:pPr indent="0" marL="0">
+              <a:buNone/>
+            </a:pPr>
+            <a:r>
+              <a:rPr lang="en-US" sz="1450" dirty="0">
+                <a:solidFill>
+                  <a:srgbClr val="1B1F24"/>
+                </a:solidFill>
+                <a:latin typeface="Inter" pitchFamily="34" charset="0"/>
+                <a:ea typeface="Inter" pitchFamily="34" charset="-122"/>
+                <a:cs typeface="Inter" pitchFamily="34" charset="-120"/>
+              </a:rPr>
+              <a:t>Level it down or scaffold it, your choice. Use the handout prompt as-is; the AI already has your artifact in the chat.</a:t>
+            </a:r>
+            <a:endParaRPr lang="en-US" sz="1450" dirty="0"/>
+          </a:p>
+        </p:txBody>
+      </p:sp>
+      <p:sp>
+        <p:nvSpPr>
+          <p:cNvPr id="17" name="Shape 14"/>
+          <p:cNvSpPr/>
+          <p:nvPr/>
+        </p:nvSpPr>
+        <p:spPr>
+          <a:xfrm>
+            <a:off x="640080" y="3611880"/>
+            <a:ext cx="5394960" cy="1874520"/>
+          </a:xfrm>
+          <a:prstGeom prst="roundRect">
+            <a:avLst>
+              <a:gd name="adj" fmla="val 4390"/>
+            </a:avLst>
+          </a:prstGeom>
+          <a:solidFill>
+            <a:srgbClr val="F7F5F0"/>
+          </a:solidFill>
+          <a:ln w="12700">
+            <a:solidFill>
+              <a:srgbClr val="F7F5F0"/>
+            </a:solidFill>
+            <a:prstDash val="solid"/>
+          </a:ln>
+        </p:spPr>
+      </p:sp>
+      <p:sp>
+        <p:nvSpPr>
+          <p:cNvPr id="18" name="Text 15"/>
+          <p:cNvSpPr/>
+          <p:nvPr/>
+        </p:nvSpPr>
+        <p:spPr>
+          <a:xfrm>
+            <a:off x="914400" y="3776472"/>
+            <a:ext cx="4846320" cy="384048"/>
+          </a:xfrm>
+          <a:prstGeom prst="rect">
+            <a:avLst/>
+          </a:prstGeom>
+          <a:noFill/>
+          <a:ln/>
+        </p:spPr>
+        <p:txBody>
+          <a:bodyPr wrap="square" lIns="0" tIns="0" rIns="0" bIns="0" rtlCol="0" anchor="ctr"/>
+          <a:lstStyle/>
+          <a:p>
+            <a:pPr indent="0" marL="0">
+              <a:buNone/>
+            </a:pPr>
+            <a:r>
+              <a:rPr lang="en-US" sz="1900" b="1" dirty="0">
+                <a:solidFill>
+                  <a:srgbClr val="2A9D8F"/>
+                </a:solidFill>
+                <a:latin typeface="Inter" pitchFamily="34" charset="0"/>
+                <a:ea typeface="Inter" pitchFamily="34" charset="-122"/>
+                <a:cs typeface="Inter" pitchFamily="34" charset="-120"/>
+              </a:rPr>
+              <a:t>Stretch</a:t>
+            </a:r>
+            <a:endParaRPr lang="en-US" sz="1900" dirty="0"/>
+          </a:p>
+        </p:txBody>
+      </p:sp>
+      <p:sp>
+        <p:nvSpPr>
+          <p:cNvPr id="19" name="Text 16"/>
+          <p:cNvSpPr/>
+          <p:nvPr/>
+        </p:nvSpPr>
+        <p:spPr>
+          <a:xfrm>
+            <a:off x="914400" y="4197096"/>
+            <a:ext cx="4846320" cy="1188720"/>
+          </a:xfrm>
+          <a:prstGeom prst="rect">
+            <a:avLst/>
+          </a:prstGeom>
+          <a:noFill/>
+          <a:ln/>
+        </p:spPr>
+        <p:txBody>
+          <a:bodyPr wrap="square" lIns="0" tIns="0" rIns="0" bIns="0" rtlCol="0" anchor="t"/>
+          <a:lstStyle/>
+          <a:p>
+            <a:pPr indent="0" marL="0">
+              <a:buNone/>
+            </a:pPr>
+            <a:r>
+              <a:rPr lang="en-US" sz="1450" dirty="0">
+                <a:solidFill>
+                  <a:srgbClr val="1B1F24"/>
+                </a:solidFill>
+                <a:latin typeface="Inter" pitchFamily="34" charset="0"/>
+                <a:ea typeface="Inter" pitchFamily="34" charset="-122"/>
+                <a:cs typeface="Inter" pitchFamily="34" charset="-120"/>
+              </a:rPr>
+              <a:t>Extension prompts: apply, critique, teach back. Depth, not length. Say “no additional practice problems.”</a:t>
+            </a:r>
+            <a:endParaRPr lang="en-US" sz="1450" dirty="0"/>
+          </a:p>
+        </p:txBody>
+      </p:sp>
+      <p:sp>
+        <p:nvSpPr>
+          <p:cNvPr id="20" name="Shape 17"/>
+          <p:cNvSpPr/>
+          <p:nvPr/>
+        </p:nvSpPr>
+        <p:spPr>
+          <a:xfrm>
+            <a:off x="6263640" y="1554480"/>
+            <a:ext cx="5394960" cy="3931920"/>
+          </a:xfrm>
+          <a:prstGeom prst="roundRect">
+            <a:avLst>
+              <a:gd name="adj" fmla="val 2093"/>
             </a:avLst>
           </a:prstGeom>
           <a:solidFill>
@@ -13840,30 +14071,72 @@
       </p:sp>
       <p:sp>
         <p:nvSpPr>
-          <p:cNvPr id="15" name="Text 12"/>
-          <p:cNvSpPr/>
-          <p:nvPr/>
-        </p:nvSpPr>
-        <p:spPr>
-          <a:xfrm>
-            <a:off x="960120" y="1828800"/>
-            <a:ext cx="4754880" cy="457200"/>
-          </a:xfrm>
-          <a:prstGeom prst="rect">
-            <a:avLst/>
-          </a:prstGeom>
-          <a:noFill/>
-          <a:ln/>
-        </p:spPr>
-        <p:txBody>
-          <a:bodyPr wrap="square" lIns="0" tIns="0" rIns="0" bIns="0" rtlCol="0" anchor="ctr"/>
-          <a:lstStyle/>
-          <a:p>
-            <a:pPr indent="0" marL="0">
-              <a:buNone/>
-            </a:pPr>
-            <a:r>
-              <a:rPr lang="en-US" sz="2200" b="1" dirty="0">
+          <p:cNvPr id="21" name="Text 18"/>
+          <p:cNvSpPr/>
+          <p:nvPr/>
+        </p:nvSpPr>
+        <p:spPr>
+          <a:xfrm>
+            <a:off x="6537960" y="1737360"/>
+            <a:ext cx="4937760" cy="292608"/>
+          </a:xfrm>
+          <a:prstGeom prst="rect">
+            <a:avLst/>
+          </a:prstGeom>
+          <a:noFill/>
+          <a:ln/>
+        </p:spPr>
+        <p:txBody>
+          <a:bodyPr wrap="square" lIns="0" tIns="0" rIns="0" bIns="0" rtlCol="0" anchor="ctr"/>
+          <a:lstStyle/>
+          <a:p>
+            <a:pPr indent="0" marL="0">
+              <a:buNone/>
+            </a:pPr>
+            <a:r>
+              <a:rPr lang="en-US" sz="1250" b="1" spc="150" kern="0" dirty="0">
+                <a:solidFill>
+                  <a:srgbClr val="2A9D8F"/>
+                </a:solidFill>
+                <a:latin typeface="Inter" pitchFamily="34" charset="0"/>
+                <a:ea typeface="Inter" pitchFamily="34" charset="-122"/>
+                <a:cs typeface="Inter" pitchFamily="34" charset="-120"/>
+              </a:rPr>
+              <a:t>MS. RIVERA'S PASSAGE · STEP 2</a:t>
+            </a:r>
+            <a:endParaRPr lang="en-US" sz="1250" dirty="0"/>
+          </a:p>
+        </p:txBody>
+      </p:sp>
+      <p:sp>
+        <p:nvSpPr>
+          <p:cNvPr id="22" name="Text 19"/>
+          <p:cNvSpPr/>
+          <p:nvPr/>
+        </p:nvSpPr>
+        <p:spPr>
+          <a:xfrm>
+            <a:off x="6537960" y="2148840"/>
+            <a:ext cx="4892040" cy="3200400"/>
+          </a:xfrm>
+          <a:prstGeom prst="rect">
+            <a:avLst/>
+          </a:prstGeom>
+          <a:noFill/>
+          <a:ln/>
+        </p:spPr>
+        <p:txBody>
+          <a:bodyPr wrap="square" lIns="0" tIns="0" rIns="0" bIns="0" rtlCol="0" anchor="t"/>
+          <a:lstStyle/>
+          <a:p>
+            <a:pPr indent="0" marL="0">
+              <a:lnSpc>
+                <a:spcPct val="120000"/>
+              </a:lnSpc>
+              <a:buNone/>
+            </a:pPr>
+            <a:r>
+              <a:rPr lang="en-US" sz="1600" b="1" dirty="0">
                 <a:solidFill>
                   <a:srgbClr val="2E7D5B"/>
                 </a:solidFill>
@@ -13871,38 +14144,16 @@
                 <a:ea typeface="Inter" pitchFamily="34" charset="-122"/>
                 <a:cs typeface="Inter" pitchFamily="34" charset="-120"/>
               </a:rPr>
-              <a:t>Support</a:t>
-            </a:r>
-            <a:endParaRPr lang="en-US" sz="2200" dirty="0"/>
-          </a:p>
-        </p:txBody>
-      </p:sp>
-      <p:sp>
-        <p:nvSpPr>
-          <p:cNvPr id="16" name="Text 13"/>
-          <p:cNvSpPr/>
-          <p:nvPr/>
-        </p:nvSpPr>
-        <p:spPr>
-          <a:xfrm>
-            <a:off x="960120" y="2377440"/>
-            <a:ext cx="4754880" cy="2651760"/>
-          </a:xfrm>
-          <a:prstGeom prst="rect">
-            <a:avLst/>
-          </a:prstGeom>
-          <a:noFill/>
-          <a:ln/>
-        </p:spPr>
-        <p:txBody>
-          <a:bodyPr wrap="square" lIns="0" tIns="0" rIns="0" bIns="0" rtlCol="0" anchor="t"/>
-          <a:lstStyle/>
-          <a:p>
-            <a:pPr indent="0" marL="0">
-              <a:buNone/>
-            </a:pPr>
-            <a:r>
-              <a:rPr lang="en-US" sz="1800" dirty="0">
+              <a:t>Support: </a:t>
+            </a:r>
+            <a:pPr indent="0" marL="0">
+              <a:lnSpc>
+                <a:spcPct val="120000"/>
+              </a:lnSpc>
+              <a:buNone/>
+            </a:pPr>
+            <a:r>
+              <a:rPr lang="en-US" sz="1600" dirty="0">
                 <a:solidFill>
                   <a:srgbClr val="1B1F24"/>
                 </a:solidFill>
@@ -13910,65 +14161,17 @@
                 <a:ea typeface="Inter" pitchFamily="34" charset="-122"/>
                 <a:cs typeface="Inter" pitchFamily="34" charset="-120"/>
               </a:rPr>
-              <a:t>Level it down or scaffold it, your choice. Use the handout prompt as-is; the AI already has your artifact in the chat.</a:t>
-            </a:r>
-            <a:endParaRPr lang="en-US" sz="1800" dirty="0"/>
-          </a:p>
-        </p:txBody>
-      </p:sp>
-      <p:sp>
-        <p:nvSpPr>
-          <p:cNvPr id="17" name="Shape 14"/>
-          <p:cNvSpPr/>
-          <p:nvPr/>
-        </p:nvSpPr>
-        <p:spPr>
-          <a:xfrm>
-            <a:off x="6263640" y="1554480"/>
-            <a:ext cx="5394960" cy="3840480"/>
-          </a:xfrm>
-          <a:prstGeom prst="roundRect">
-            <a:avLst>
-              <a:gd name="adj" fmla="val 2143"/>
-            </a:avLst>
-          </a:prstGeom>
-          <a:solidFill>
-            <a:srgbClr val="F7F5F0"/>
-          </a:solidFill>
-          <a:ln w="12700">
-            <a:solidFill>
-              <a:srgbClr val="F7F5F0"/>
-            </a:solidFill>
-            <a:prstDash val="solid"/>
-          </a:ln>
-        </p:spPr>
-      </p:sp>
-      <p:sp>
-        <p:nvSpPr>
-          <p:cNvPr id="18" name="Text 15"/>
-          <p:cNvSpPr/>
-          <p:nvPr/>
-        </p:nvSpPr>
-        <p:spPr>
-          <a:xfrm>
-            <a:off x="6583680" y="1828800"/>
-            <a:ext cx="4754880" cy="457200"/>
-          </a:xfrm>
-          <a:prstGeom prst="rect">
-            <a:avLst/>
-          </a:prstGeom>
-          <a:noFill/>
-          <a:ln/>
-        </p:spPr>
-        <p:txBody>
-          <a:bodyPr wrap="square" lIns="0" tIns="0" rIns="0" bIns="0" rtlCol="0" anchor="ctr"/>
-          <a:lstStyle/>
-          <a:p>
-            <a:pPr indent="0" marL="0">
-              <a:buNone/>
-            </a:pPr>
-            <a:r>
-              <a:rPr lang="en-US" sz="2200" b="1" dirty="0">
+              <a:t>her passage leveled down. Sentences under 12 words, plus a 5-word vocabulary box.
+</a:t>
+            </a:r>
+            <a:pPr indent="0" marL="0">
+              <a:lnSpc>
+                <a:spcPct val="120000"/>
+              </a:lnSpc>
+              <a:buNone/>
+            </a:pPr>
+            <a:r>
+              <a:rPr lang="en-US" sz="1600" b="1" dirty="0">
                 <a:solidFill>
                   <a:srgbClr val="2A9D8F"/>
                 </a:solidFill>
@@ -13976,38 +14179,16 @@
                 <a:ea typeface="Inter" pitchFamily="34" charset="-122"/>
                 <a:cs typeface="Inter" pitchFamily="34" charset="-120"/>
               </a:rPr>
-              <a:t>Stretch</a:t>
-            </a:r>
-            <a:endParaRPr lang="en-US" sz="2200" dirty="0"/>
-          </a:p>
-        </p:txBody>
-      </p:sp>
-      <p:sp>
-        <p:nvSpPr>
-          <p:cNvPr id="19" name="Text 16"/>
-          <p:cNvSpPr/>
-          <p:nvPr/>
-        </p:nvSpPr>
-        <p:spPr>
-          <a:xfrm>
-            <a:off x="6583680" y="2377440"/>
-            <a:ext cx="4754880" cy="2651760"/>
-          </a:xfrm>
-          <a:prstGeom prst="rect">
-            <a:avLst/>
-          </a:prstGeom>
-          <a:noFill/>
-          <a:ln/>
-        </p:spPr>
-        <p:txBody>
-          <a:bodyPr wrap="square" lIns="0" tIns="0" rIns="0" bIns="0" rtlCol="0" anchor="t"/>
-          <a:lstStyle/>
-          <a:p>
-            <a:pPr indent="0" marL="0">
-              <a:buNone/>
-            </a:pPr>
-            <a:r>
-              <a:rPr lang="en-US" sz="1800" dirty="0">
+              <a:t>Stretch: </a:t>
+            </a:r>
+            <a:pPr indent="0" marL="0">
+              <a:lnSpc>
+                <a:spcPct val="120000"/>
+              </a:lnSpc>
+              <a:buNone/>
+            </a:pPr>
+            <a:r>
+              <a:rPr lang="en-US" sz="1600" dirty="0">
                 <a:solidFill>
                   <a:srgbClr val="1B1F24"/>
                 </a:solidFill>
@@ -14015,21 +14196,39 @@
                 <a:ea typeface="Inter" pitchFamily="34" charset="-122"/>
                 <a:cs typeface="Inter" pitchFamily="34" charset="-120"/>
               </a:rPr>
-              <a:t>Extension prompts: apply, critique, teach back. Depth, not length. Say “no additional practice problems.”</a:t>
-            </a:r>
-            <a:endParaRPr lang="en-US" sz="1800" dirty="0"/>
-          </a:p>
-        </p:txBody>
-      </p:sp>
-      <p:sp>
-        <p:nvSpPr>
-          <p:cNvPr id="20" name="Text 17"/>
-          <p:cNvSpPr/>
-          <p:nvPr/>
-        </p:nvSpPr>
-        <p:spPr>
-          <a:xfrm>
-            <a:off x="640080" y="5623560"/>
+              <a:t>three depth prompts: apply it to a desert food web, find the flaw in a broken one, teach it to a 3rd grader.
+</a:t>
+            </a:r>
+            <a:pPr indent="0" marL="0">
+              <a:lnSpc>
+                <a:spcPct val="120000"/>
+              </a:lnSpc>
+              <a:buNone/>
+            </a:pPr>
+            <a:r>
+              <a:rPr lang="en-US" sz="1600" i="1" dirty="0">
+                <a:solidFill>
+                  <a:srgbClr val="5B6B7A"/>
+                </a:solidFill>
+                <a:latin typeface="Inter" pitchFamily="34" charset="0"/>
+                <a:ea typeface="Inter" pitchFamily="34" charset="-122"/>
+                <a:cs typeface="Inter" pitchFamily="34" charset="-120"/>
+              </a:rPr>
+              <a:t>"Two follow-ups in the same chat. It already has my passage."</a:t>
+            </a:r>
+            <a:endParaRPr lang="en-US" sz="1600" dirty="0"/>
+          </a:p>
+        </p:txBody>
+      </p:sp>
+      <p:sp>
+        <p:nvSpPr>
+          <p:cNvPr id="23" name="Text 20"/>
+          <p:cNvSpPr/>
+          <p:nvPr/>
+        </p:nvSpPr>
+        <p:spPr>
+          <a:xfrm>
+            <a:off x="640080" y="5715000"/>
             <a:ext cx="10972800" cy="457200"/>
           </a:xfrm>
           <a:prstGeom prst="rect">
@@ -14409,7 +14608,7 @@
                 <a:ea typeface="Inter" pitchFamily="34" charset="-122"/>
                 <a:cs typeface="Inter" pitchFamily="34" charset="-120"/>
               </a:rPr>
-              <a:t>Her review, run live: caught one off-level sentence, fixed the examples.</a:t>
+              <a:t>Her passage's review, run live: one long sentence split, one example swapped.</a:t>
             </a:r>
             <a:endParaRPr lang="en-US" sz="1000" dirty="0"/>
           </a:p>
@@ -14463,23 +14662,23 @@
         <p:spPr>
           <a:xfrm>
             <a:off x="548640" y="384048"/>
-            <a:ext cx="11091672" cy="777240"/>
-          </a:xfrm>
-          <a:prstGeom prst="rect">
-            <a:avLst/>
-          </a:prstGeom>
-          <a:noFill/>
-          <a:ln/>
-        </p:spPr>
-        <p:txBody>
-          <a:bodyPr wrap="square" lIns="0" tIns="0" rIns="0" bIns="0" rtlCol="0" anchor="ctr"/>
-          <a:lstStyle/>
-          <a:p>
-            <a:pPr indent="0" marL="0">
-              <a:buNone/>
-            </a:pPr>
-            <a:r>
-              <a:rPr lang="en-US" sz="3200" b="1" dirty="0">
+            <a:ext cx="7955280" cy="777240"/>
+          </a:xfrm>
+          <a:prstGeom prst="rect">
+            <a:avLst/>
+          </a:prstGeom>
+          <a:noFill/>
+          <a:ln/>
+        </p:spPr>
+        <p:txBody>
+          <a:bodyPr wrap="square" lIns="0" tIns="0" rIns="0" bIns="0" rtlCol="0" anchor="ctr"/>
+          <a:lstStyle/>
+          <a:p>
+            <a:pPr indent="0" marL="0">
+              <a:buNone/>
+            </a:pPr>
+            <a:r>
+              <a:rPr lang="en-US" sz="2800" b="1" dirty="0">
                 <a:solidFill>
                   <a:srgbClr val="13293D"/>
                 </a:solidFill>
@@ -14489,32 +14688,138 @@
               </a:rPr>
               <a:t>Run the 4-point review. Fix what fails.</a:t>
             </a:r>
-            <a:endParaRPr lang="en-US" sz="3200" dirty="0"/>
-          </a:p>
-        </p:txBody>
-      </p:sp>
-      <p:sp>
-        <p:nvSpPr>
-          <p:cNvPr id="14" name="Shape 11"/>
-          <p:cNvSpPr/>
-          <p:nvPr/>
-        </p:nvSpPr>
-        <p:spPr>
-          <a:xfrm>
-            <a:off x="640080" y="1508760"/>
-            <a:ext cx="10972800" cy="731520"/>
+            <a:endParaRPr lang="en-US" sz="2800" dirty="0"/>
+          </a:p>
+        </p:txBody>
+      </p:sp>
+      <p:sp>
+        <p:nvSpPr>
+          <p:cNvPr id="14" name="Text 11"/>
+          <p:cNvSpPr/>
+          <p:nvPr/>
+        </p:nvSpPr>
+        <p:spPr>
+          <a:xfrm>
+            <a:off x="640080" y="1554480"/>
+            <a:ext cx="5394960" cy="4023360"/>
+          </a:xfrm>
+          <a:prstGeom prst="rect">
+            <a:avLst/>
+          </a:prstGeom>
+          <a:noFill/>
+          <a:ln/>
+        </p:spPr>
+        <p:txBody>
+          <a:bodyPr wrap="square" rtlCol="0" anchor="t"/>
+          <a:lstStyle/>
+          <a:p>
+            <a:pPr marL="342900" indent="-342900">
+              <a:spcAft>
+                <a:spcPts val="1000"/>
+              </a:spcAft>
+              <a:buSzPct val="100000"/>
+              <a:buChar char="•"/>
+            </a:pPr>
+            <a:r>
+              <a:rPr lang="en-US" sz="1650" dirty="0">
+                <a:solidFill>
+                  <a:srgbClr val="1B1F24"/>
+                </a:solidFill>
+                <a:latin typeface="Inter" pitchFamily="34" charset="0"/>
+                <a:ea typeface="Inter" pitchFamily="34" charset="-122"/>
+                <a:cs typeface="Inter" pitchFamily="34" charset="-120"/>
+              </a:rPr>
+              <a:t>Accurate? Check facts and any named resources</a:t>
+            </a:r>
+            <a:endParaRPr lang="en-US" sz="1650" dirty="0"/>
+          </a:p>
+          <a:p>
+            <a:pPr marL="342900" indent="-342900">
+              <a:spcAft>
+                <a:spcPts val="1000"/>
+              </a:spcAft>
+              <a:buSzPct val="100000"/>
+              <a:buChar char="•"/>
+            </a:pPr>
+            <a:r>
+              <a:rPr lang="en-US" sz="1650" dirty="0">
+                <a:solidFill>
+                  <a:srgbClr val="1B1F24"/>
+                </a:solidFill>
+                <a:latin typeface="Inter" pitchFamily="34" charset="0"/>
+                <a:ea typeface="Inter" pitchFamily="34" charset="-122"/>
+                <a:cs typeface="Inter" pitchFamily="34" charset="-120"/>
+              </a:rPr>
+              <a:t>At level, actually? Read the support version aloud to your partner</a:t>
+            </a:r>
+            <a:endParaRPr lang="en-US" sz="1650" dirty="0"/>
+          </a:p>
+          <a:p>
+            <a:pPr marL="342900" indent="-342900">
+              <a:spcAft>
+                <a:spcPts val="1000"/>
+              </a:spcAft>
+              <a:buSzPct val="100000"/>
+              <a:buChar char="•"/>
+            </a:pPr>
+            <a:r>
+              <a:rPr lang="en-US" sz="1650" dirty="0">
+                <a:solidFill>
+                  <a:srgbClr val="1B1F24"/>
+                </a:solidFill>
+                <a:latin typeface="Inter" pitchFamily="34" charset="0"/>
+                <a:ea typeface="Inter" pitchFamily="34" charset="-122"/>
+                <a:cs typeface="Inter" pitchFamily="34" charset="-120"/>
+              </a:rPr>
+              <a:t>Fits your students? Swap the examples that won’t land</a:t>
+            </a:r>
+            <a:endParaRPr lang="en-US" sz="1650" dirty="0"/>
+          </a:p>
+          <a:p>
+            <a:pPr marL="342900" indent="-342900">
+              <a:spcAft>
+                <a:spcPts val="1000"/>
+              </a:spcAft>
+              <a:buSzPct val="100000"/>
+              <a:buChar char="•"/>
+            </a:pPr>
+            <a:r>
+              <a:rPr lang="en-US" sz="1650" dirty="0">
+                <a:solidFill>
+                  <a:srgbClr val="1B1F24"/>
+                </a:solidFill>
+                <a:latin typeface="Inter" pitchFamily="34" charset="0"/>
+                <a:ea typeface="Inter" pitchFamily="34" charset="-122"/>
+                <a:cs typeface="Inter" pitchFamily="34" charset="-120"/>
+              </a:rPr>
+              <a:t>Sounds like you? If not: “warmer,” “plainer,” “shorter”</a:t>
+            </a:r>
+            <a:endParaRPr lang="en-US" sz="1650" dirty="0"/>
+          </a:p>
+        </p:txBody>
+      </p:sp>
+      <p:sp>
+        <p:nvSpPr>
+          <p:cNvPr id="15" name="Shape 12"/>
+          <p:cNvSpPr/>
+          <p:nvPr/>
+        </p:nvSpPr>
+        <p:spPr>
+          <a:xfrm>
+            <a:off x="6263640" y="1554480"/>
+            <a:ext cx="5394960" cy="4023360"/>
           </a:xfrm>
           <a:prstGeom prst="roundRect">
             <a:avLst>
-              <a:gd name="adj" fmla="val 11250"/>
+              <a:gd name="adj" fmla="val 2045"/>
             </a:avLst>
           </a:prstGeom>
           <a:solidFill>
-            <a:srgbClr val="F7F5F0"/>
+            <a:srgbClr val="EAF5F3"/>
           </a:solidFill>
           <a:ln w="12700">
             <a:solidFill>
-              <a:srgbClr val="F7F5F0"/>
+              <a:srgbClr val="EAF5F3"/>
             </a:solidFill>
             <a:prstDash val="solid"/>
           </a:ln>
@@ -14522,30 +14827,89 @@
       </p:sp>
       <p:sp>
         <p:nvSpPr>
-          <p:cNvPr id="15" name="Text 12"/>
-          <p:cNvSpPr/>
-          <p:nvPr/>
-        </p:nvSpPr>
-        <p:spPr>
-          <a:xfrm>
-            <a:off x="960120" y="1563624"/>
-            <a:ext cx="10332720" cy="621792"/>
-          </a:xfrm>
-          <a:prstGeom prst="rect">
-            <a:avLst/>
-          </a:prstGeom>
-          <a:noFill/>
-          <a:ln/>
-        </p:spPr>
-        <p:txBody>
-          <a:bodyPr wrap="square" lIns="0" tIns="0" rIns="0" bIns="0" rtlCol="0" anchor="ctr"/>
-          <a:lstStyle/>
-          <a:p>
-            <a:pPr indent="0" marL="0">
-              <a:buNone/>
-            </a:pPr>
-            <a:r>
-              <a:rPr lang="en-US" sz="1800" dirty="0">
+          <p:cNvPr id="16" name="Text 13"/>
+          <p:cNvSpPr/>
+          <p:nvPr/>
+        </p:nvSpPr>
+        <p:spPr>
+          <a:xfrm>
+            <a:off x="6537960" y="1737360"/>
+            <a:ext cx="4937760" cy="292608"/>
+          </a:xfrm>
+          <a:prstGeom prst="rect">
+            <a:avLst/>
+          </a:prstGeom>
+          <a:noFill/>
+          <a:ln/>
+        </p:spPr>
+        <p:txBody>
+          <a:bodyPr wrap="square" lIns="0" tIns="0" rIns="0" bIns="0" rtlCol="0" anchor="ctr"/>
+          <a:lstStyle/>
+          <a:p>
+            <a:pPr indent="0" marL="0">
+              <a:buNone/>
+            </a:pPr>
+            <a:r>
+              <a:rPr lang="en-US" sz="1250" b="1" spc="150" kern="0" dirty="0">
+                <a:solidFill>
+                  <a:srgbClr val="2A9D8F"/>
+                </a:solidFill>
+                <a:latin typeface="Inter" pitchFamily="34" charset="0"/>
+                <a:ea typeface="Inter" pitchFamily="34" charset="-122"/>
+                <a:cs typeface="Inter" pitchFamily="34" charset="-120"/>
+              </a:rPr>
+              <a:t>MS. RIVERA'S PASSAGE · STEP 3</a:t>
+            </a:r>
+            <a:endParaRPr lang="en-US" sz="1250" dirty="0"/>
+          </a:p>
+        </p:txBody>
+      </p:sp>
+      <p:sp>
+        <p:nvSpPr>
+          <p:cNvPr id="17" name="Text 14"/>
+          <p:cNvSpPr/>
+          <p:nvPr/>
+        </p:nvSpPr>
+        <p:spPr>
+          <a:xfrm>
+            <a:off x="6537960" y="2148840"/>
+            <a:ext cx="4892040" cy="3291840"/>
+          </a:xfrm>
+          <a:prstGeom prst="rect">
+            <a:avLst/>
+          </a:prstGeom>
+          <a:noFill/>
+          <a:ln/>
+        </p:spPr>
+        <p:txBody>
+          <a:bodyPr wrap="square" lIns="0" tIns="0" rIns="0" bIns="0" rtlCol="0" anchor="t"/>
+          <a:lstStyle/>
+          <a:p>
+            <a:pPr indent="0" marL="0">
+              <a:lnSpc>
+                <a:spcPct val="120000"/>
+              </a:lnSpc>
+              <a:buNone/>
+            </a:pPr>
+            <a:r>
+              <a:rPr lang="en-US" sz="1550" b="1" dirty="0">
+                <a:solidFill>
+                  <a:srgbClr val="2E7D5B"/>
+                </a:solidFill>
+                <a:latin typeface="Inter" pitchFamily="34" charset="0"/>
+                <a:ea typeface="Inter" pitchFamily="34" charset="-122"/>
+                <a:cs typeface="Inter" pitchFamily="34" charset="-120"/>
+              </a:rPr>
+              <a:t>Accurate: </a:t>
+            </a:r>
+            <a:pPr indent="0" marL="0">
+              <a:lnSpc>
+                <a:spcPct val="120000"/>
+              </a:lnSpc>
+              <a:buNone/>
+            </a:pPr>
+            <a:r>
+              <a:rPr lang="en-US" sz="1550" dirty="0">
                 <a:solidFill>
                   <a:srgbClr val="1B1F24"/>
                 </a:solidFill>
@@ -14553,65 +14917,34 @@
                 <a:ea typeface="Inter" pitchFamily="34" charset="-122"/>
                 <a:cs typeface="Inter" pitchFamily="34" charset="-120"/>
               </a:rPr>
-              <a:t>Accurate? Check facts and any named resources</a:t>
-            </a:r>
-            <a:endParaRPr lang="en-US" sz="1800" dirty="0"/>
-          </a:p>
-        </p:txBody>
-      </p:sp>
-      <p:sp>
-        <p:nvSpPr>
-          <p:cNvPr id="16" name="Shape 13"/>
-          <p:cNvSpPr/>
-          <p:nvPr/>
-        </p:nvSpPr>
-        <p:spPr>
-          <a:xfrm>
-            <a:off x="640080" y="2377440"/>
-            <a:ext cx="10972800" cy="731520"/>
-          </a:xfrm>
-          <a:prstGeom prst="roundRect">
-            <a:avLst>
-              <a:gd name="adj" fmla="val 11250"/>
-            </a:avLst>
-          </a:prstGeom>
-          <a:solidFill>
-            <a:srgbClr val="F7F5F0"/>
-          </a:solidFill>
-          <a:ln w="12700">
-            <a:solidFill>
-              <a:srgbClr val="F7F5F0"/>
-            </a:solidFill>
-            <a:prstDash val="solid"/>
-          </a:ln>
-        </p:spPr>
-      </p:sp>
-      <p:sp>
-        <p:nvSpPr>
-          <p:cNvPr id="17" name="Text 14"/>
-          <p:cNvSpPr/>
-          <p:nvPr/>
-        </p:nvSpPr>
-        <p:spPr>
-          <a:xfrm>
-            <a:off x="960120" y="2432304"/>
-            <a:ext cx="10332720" cy="621792"/>
-          </a:xfrm>
-          <a:prstGeom prst="rect">
-            <a:avLst/>
-          </a:prstGeom>
-          <a:noFill/>
-          <a:ln/>
-        </p:spPr>
-        <p:txBody>
-          <a:bodyPr wrap="square" lIns="0" tIns="0" rIns="0" bIns="0" rtlCol="0" anchor="ctr"/>
-          <a:lstStyle/>
-          <a:p>
-            <a:pPr indent="0" marL="0">
-              <a:buNone/>
-            </a:pPr>
-            <a:r>
-              <a:rPr lang="en-US" sz="1800" dirty="0">
+              <a:t>passes. Every fact and resource checks out.
+</a:t>
+            </a:r>
+            <a:pPr indent="0" marL="0">
+              <a:lnSpc>
+                <a:spcPct val="120000"/>
+              </a:lnSpc>
+              <a:buNone/>
+            </a:pPr>
+            <a:r>
+              <a:rPr lang="en-US" sz="1550" b="1" dirty="0">
+                <a:solidFill>
+                  <a:srgbClr val="B4453A"/>
+                </a:solidFill>
+                <a:latin typeface="Inter" pitchFamily="34" charset="0"/>
+                <a:ea typeface="Inter" pitchFamily="34" charset="-122"/>
+                <a:cs typeface="Inter" pitchFamily="34" charset="-120"/>
+              </a:rPr>
+              <a:t>At level: </a:t>
+            </a:r>
+            <a:pPr indent="0" marL="0">
+              <a:lnSpc>
+                <a:spcPct val="120000"/>
+              </a:lnSpc>
+              <a:buNone/>
+            </a:pPr>
+            <a:r>
+              <a:rPr lang="en-US" sz="1550" dirty="0">
                 <a:solidFill>
                   <a:srgbClr val="1B1F24"/>
                 </a:solidFill>
@@ -14619,65 +14952,34 @@
                 <a:ea typeface="Inter" pitchFamily="34" charset="-122"/>
                 <a:cs typeface="Inter" pitchFamily="34" charset="-120"/>
               </a:rPr>
-              <a:t>At level, actually? Read the support version aloud to your partner</a:t>
-            </a:r>
-            <a:endParaRPr lang="en-US" sz="1800" dirty="0"/>
-          </a:p>
-        </p:txBody>
-      </p:sp>
-      <p:sp>
-        <p:nvSpPr>
-          <p:cNvPr id="18" name="Shape 15"/>
-          <p:cNvSpPr/>
-          <p:nvPr/>
-        </p:nvSpPr>
-        <p:spPr>
-          <a:xfrm>
-            <a:off x="640080" y="3246120"/>
-            <a:ext cx="10972800" cy="731520"/>
-          </a:xfrm>
-          <a:prstGeom prst="roundRect">
-            <a:avLst>
-              <a:gd name="adj" fmla="val 11250"/>
-            </a:avLst>
-          </a:prstGeom>
-          <a:solidFill>
-            <a:srgbClr val="F7F5F0"/>
-          </a:solidFill>
-          <a:ln w="12700">
-            <a:solidFill>
-              <a:srgbClr val="F7F5F0"/>
-            </a:solidFill>
-            <a:prstDash val="solid"/>
-          </a:ln>
-        </p:spPr>
-      </p:sp>
-      <p:sp>
-        <p:nvSpPr>
-          <p:cNvPr id="19" name="Text 16"/>
-          <p:cNvSpPr/>
-          <p:nvPr/>
-        </p:nvSpPr>
-        <p:spPr>
-          <a:xfrm>
-            <a:off x="960120" y="3300984"/>
-            <a:ext cx="10332720" cy="621792"/>
-          </a:xfrm>
-          <a:prstGeom prst="rect">
-            <a:avLst/>
-          </a:prstGeom>
-          <a:noFill/>
-          <a:ln/>
-        </p:spPr>
-        <p:txBody>
-          <a:bodyPr wrap="square" lIns="0" tIns="0" rIns="0" bIns="0" rtlCol="0" anchor="ctr"/>
-          <a:lstStyle/>
-          <a:p>
-            <a:pPr indent="0" marL="0">
-              <a:buNone/>
-            </a:pPr>
-            <a:r>
-              <a:rPr lang="en-US" sz="1800" dirty="0">
+              <a:t>one 24-word sentence in the support version. Split it in the chat.
+</a:t>
+            </a:r>
+            <a:pPr indent="0" marL="0">
+              <a:lnSpc>
+                <a:spcPct val="120000"/>
+              </a:lnSpc>
+              <a:buNone/>
+            </a:pPr>
+            <a:r>
+              <a:rPr lang="en-US" sz="1550" b="1" dirty="0">
+                <a:solidFill>
+                  <a:srgbClr val="B4453A"/>
+                </a:solidFill>
+                <a:latin typeface="Inter" pitchFamily="34" charset="0"/>
+                <a:ea typeface="Inter" pitchFamily="34" charset="-122"/>
+                <a:cs typeface="Inter" pitchFamily="34" charset="-120"/>
+              </a:rPr>
+              <a:t>Fits her kids: </a:t>
+            </a:r>
+            <a:pPr indent="0" marL="0">
+              <a:lnSpc>
+                <a:spcPct val="120000"/>
+              </a:lnSpc>
+              <a:buNone/>
+            </a:pPr>
+            <a:r>
+              <a:rPr lang="en-US" sz="1550" dirty="0">
                 <a:solidFill>
                   <a:srgbClr val="1B1F24"/>
                 </a:solidFill>
@@ -14685,65 +14987,34 @@
                 <a:ea typeface="Inter" pitchFamily="34" charset="-122"/>
                 <a:cs typeface="Inter" pitchFamily="34" charset="-120"/>
               </a:rPr>
-              <a:t>Fits your students? Swap the examples that won’t land</a:t>
-            </a:r>
-            <a:endParaRPr lang="en-US" sz="1800" dirty="0"/>
-          </a:p>
-        </p:txBody>
-      </p:sp>
-      <p:sp>
-        <p:nvSpPr>
-          <p:cNvPr id="20" name="Shape 17"/>
-          <p:cNvSpPr/>
-          <p:nvPr/>
-        </p:nvSpPr>
-        <p:spPr>
-          <a:xfrm>
-            <a:off x="640080" y="4114800"/>
-            <a:ext cx="10972800" cy="731520"/>
-          </a:xfrm>
-          <a:prstGeom prst="roundRect">
-            <a:avLst>
-              <a:gd name="adj" fmla="val 11250"/>
-            </a:avLst>
-          </a:prstGeom>
-          <a:solidFill>
-            <a:srgbClr val="F7F5F0"/>
-          </a:solidFill>
-          <a:ln w="12700">
-            <a:solidFill>
-              <a:srgbClr val="F7F5F0"/>
-            </a:solidFill>
-            <a:prstDash val="solid"/>
-          </a:ln>
-        </p:spPr>
-      </p:sp>
-      <p:sp>
-        <p:nvSpPr>
-          <p:cNvPr id="21" name="Text 18"/>
-          <p:cNvSpPr/>
-          <p:nvPr/>
-        </p:nvSpPr>
-        <p:spPr>
-          <a:xfrm>
-            <a:off x="960120" y="4169664"/>
-            <a:ext cx="10332720" cy="621792"/>
-          </a:xfrm>
-          <a:prstGeom prst="rect">
-            <a:avLst/>
-          </a:prstGeom>
-          <a:noFill/>
-          <a:ln/>
-        </p:spPr>
-        <p:txBody>
-          <a:bodyPr wrap="square" lIns="0" tIns="0" rIns="0" bIns="0" rtlCol="0" anchor="ctr"/>
-          <a:lstStyle/>
-          <a:p>
-            <a:pPr indent="0" marL="0">
-              <a:buNone/>
-            </a:pPr>
-            <a:r>
-              <a:rPr lang="en-US" sz="1800" dirty="0">
+              <a:t>the ocean example swapped for the schoolyard one.
+</a:t>
+            </a:r>
+            <a:pPr indent="0" marL="0">
+              <a:lnSpc>
+                <a:spcPct val="120000"/>
+              </a:lnSpc>
+              <a:buNone/>
+            </a:pPr>
+            <a:r>
+              <a:rPr lang="en-US" sz="1550" b="1" dirty="0">
+                <a:solidFill>
+                  <a:srgbClr val="2E7D5B"/>
+                </a:solidFill>
+                <a:latin typeface="Inter" pitchFamily="34" charset="0"/>
+                <a:ea typeface="Inter" pitchFamily="34" charset="-122"/>
+                <a:cs typeface="Inter" pitchFamily="34" charset="-120"/>
+              </a:rPr>
+              <a:t>Sounds like her: </a:t>
+            </a:r>
+            <a:pPr indent="0" marL="0">
+              <a:lnSpc>
+                <a:spcPct val="120000"/>
+              </a:lnSpc>
+              <a:buNone/>
+            </a:pPr>
+            <a:r>
+              <a:rPr lang="en-US" sz="1550" dirty="0">
                 <a:solidFill>
                   <a:srgbClr val="1B1F24"/>
                 </a:solidFill>
@@ -14751,21 +15022,39 @@
                 <a:ea typeface="Inter" pitchFamily="34" charset="-122"/>
                 <a:cs typeface="Inter" pitchFamily="34" charset="-120"/>
               </a:rPr>
-              <a:t>Sounds like you? If not: “warmer,” “plainer,” “shorter”</a:t>
-            </a:r>
-            <a:endParaRPr lang="en-US" sz="1800" dirty="0"/>
-          </a:p>
-        </p:txBody>
-      </p:sp>
-      <p:sp>
-        <p:nvSpPr>
-          <p:cNvPr id="22" name="Text 19"/>
-          <p:cNvSpPr/>
-          <p:nvPr/>
-        </p:nvSpPr>
-        <p:spPr>
-          <a:xfrm>
-            <a:off x="640080" y="5212080"/>
+              <a:t>passes, after one follow-up: “plainer.”
+</a:t>
+            </a:r>
+            <a:pPr indent="0" marL="0">
+              <a:lnSpc>
+                <a:spcPct val="120000"/>
+              </a:lnSpc>
+              <a:buNone/>
+            </a:pPr>
+            <a:r>
+              <a:rPr lang="en-US" sz="1550" i="1" dirty="0">
+                <a:solidFill>
+                  <a:srgbClr val="5B6B7A"/>
+                </a:solidFill>
+                <a:latin typeface="Inter" pitchFamily="34" charset="0"/>
+                <a:ea typeface="Inter" pitchFamily="34" charset="-122"/>
+                <a:cs typeface="Inter" pitchFamily="34" charset="-120"/>
+              </a:rPr>
+              <a:t>"Two fixes, four passes, while the chat was open."</a:t>
+            </a:r>
+            <a:endParaRPr lang="en-US" sz="1550" dirty="0"/>
+          </a:p>
+        </p:txBody>
+      </p:sp>
+      <p:sp>
+        <p:nvSpPr>
+          <p:cNvPr id="18" name="Text 15"/>
+          <p:cNvSpPr/>
+          <p:nvPr/>
+        </p:nvSpPr>
+        <p:spPr>
+          <a:xfrm>
+            <a:off x="640080" y="5715000"/>
             <a:ext cx="10972800" cy="457200"/>
           </a:xfrm>
           <a:prstGeom prst="rect">
@@ -15145,7 +15434,7 @@
                 <a:ea typeface="Inter" pitchFamily="34" charset="-122"/>
                 <a:cs typeface="Inter" pitchFamily="34" charset="-120"/>
               </a:rPr>
-              <a:t>Her artifacts: core, support, stretch. An evening's work in twenty minutes.</a:t>
+              <a:t>Her share-out: what the review caught in her food webs passage, told first.</a:t>
             </a:r>
             <a:endParaRPr lang="en-US" sz="1000" dirty="0"/>
           </a:p>
@@ -15663,7 +15952,7 @@
                 <a:ea typeface="Inter" pitchFamily="34" charset="-122"/>
                 <a:cs typeface="Inter" pitchFamily="34" charset="-120"/>
               </a:rPr>
-              <a:t>Her materials now match her intentions. That was the whole gap.</a:t>
+              <a:t>Her inventory, one passage: core, support, stretch, all four points passed.</a:t>
             </a:r>
             <a:endParaRPr lang="en-US" sz="1000" dirty="0"/>
           </a:p>

</xml_diff>